<commit_message>
tablero de pronunciación interactivo
</commit_message>
<xml_diff>
--- a/Taller_6Junio/Certificados/Certificado_Taller_Hangul_PROFESIONAL [Autosaved].pptx
+++ b/Taller_6Junio/Certificados/Certificado_Taller_Hangul_PROFESIONAL [Autosaved].pptx
@@ -865,8 +865,8 @@
         </p:nvSpPr>
         <p:spPr>
           <a:xfrm>
-            <a:off x="2697480" y="3493008"/>
-            <a:ext cx="5303520" cy="502920"/>
+            <a:off x="2381409" y="3493008"/>
+            <a:ext cx="5925820" cy="502920"/>
           </a:xfrm>
           <a:prstGeom prst="rect">
             <a:avLst/>
@@ -881,6 +881,10 @@
             <a:pPr marL="0" indent="0" algn="ctr">
               <a:buNone/>
             </a:pPr>
+            <a:r>
+              <a:rPr lang="ko-KR" altLang="es-CL" sz="2400" b="1" dirty="0"/>
+              <a:t>신티아 발렌티나 발데스 곤살레스</a:t>
+            </a:r>
             <a:endParaRPr lang="en-US" sz="2400" b="1" dirty="0"/>
           </a:p>
         </p:txBody>

</xml_diff>

<commit_message>
Marca: nuevo eslogan 'Con un chingu' en hero y foote
</commit_message>
<xml_diff>
--- a/Taller_6Junio/Certificados/Certificado_Taller_Hangul_PROFESIONAL [Autosaved].pptx
+++ b/Taller_6Junio/Certificados/Certificado_Taller_Hangul_PROFESIONAL [Autosaved].pptx
@@ -882,8 +882,8 @@
               <a:buNone/>
             </a:pPr>
             <a:r>
-              <a:rPr lang="ko-KR" altLang="es-CL" sz="2400" b="1" dirty="0"/>
-              <a:t>신티아 발렌티나 발데스 곤살레스</a:t>
+              <a:rPr lang="ko-KR" altLang="es-CL" sz="2400" b="1"/>
+              <a:t>옐리스 에르난데스</a:t>
             </a:r>
             <a:endParaRPr lang="en-US" sz="2400" b="1" dirty="0"/>
           </a:p>

</xml_diff>